<commit_message>
feat: add executive brief feature with frontend components, backend services, tests, and validation reports
</commit_message>
<xml_diff>
--- a/EXECUTIVE_BRIEF.pptx
+++ b/EXECUTIVE_BRIEF.pptx
@@ -8647,7 +8647,7 @@
                   <a:srgbClr val="CBD5E1"/>
                 </a:solidFill>
               </a:rPr>
-              <a:t>BACKGROUND: Decentralized plant purchase orders across 6 regional manufacturing clusters.</a:t>
+              <a:t>BACKGROUND: Decentralized plant purchase orders across 6 regional manufacturing clusters cause rate creep</a:t>
             </a:r>
             <a:endParaRPr lang="en-US" sz="750" dirty="0"/>
           </a:p>
@@ -8667,7 +8667,7 @@
                   <a:srgbClr val="CBD5E1"/>
                 </a:solidFill>
               </a:rPr>
-              <a:t>EVIDENCE: 340 standardized repeat items exhibit an average unit price spread of 18.5% across plants.</a:t>
+              <a:t>EVIDENCE: 340 standardized repeat items exhibit an average unit price spread of 18.5% across plants</a:t>
             </a:r>
             <a:endParaRPr lang="en-US" sz="750" dirty="0"/>
           </a:p>
@@ -8687,7 +8687,7 @@
                   <a:srgbClr val="CBD5E1"/>
                 </a:solidFill>
               </a:rPr>
-              <a:t>NEXT STEP: Issue centralized corporate rate contracts with indexed regional logistics adders.</a:t>
+              <a:t>NEXT STEP: Issue centralized corporate rate contracts with indexed regional logistics adders</a:t>
             </a:r>
             <a:endParaRPr lang="en-US" sz="750" dirty="0"/>
           </a:p>
@@ -8820,7 +8820,7 @@
                   <a:srgbClr val="CBD5E1"/>
                 </a:solidFill>
               </a:rPr>
-              <a:t>BACKGROUND: Active supplier master audit evaluating transaction density and cumulative spend share.</a:t>
+              <a:t>BACKGROUND: Active supplier master audit evaluating transaction density and cumulative spend share</a:t>
             </a:r>
             <a:endParaRPr lang="en-US" sz="750" dirty="0"/>
           </a:p>
@@ -8840,7 +8840,7 @@
                   <a:srgbClr val="CBD5E1"/>
                 </a:solidFill>
               </a:rPr>
-              <a:t>EVIDENCE: 912 vendors (61.5% of vendor base) account for only 4.8% of spend (₹236.00 Cr).</a:t>
+              <a:t>EVIDENCE: 912 vendors (61.5% of vendor base) account for only 4.8% of spend (₹236.00 Cr)</a:t>
             </a:r>
             <a:endParaRPr lang="en-US" sz="750" dirty="0"/>
           </a:p>
@@ -8860,7 +8860,7 @@
                   <a:srgbClr val="CBD5E1"/>
                 </a:solidFill>
               </a:rPr>
-              <a:t>NEXT STEP: Execute vendor consolidation wave transitioning 912 tail vendors to 180 certified partners.</a:t>
+              <a:t>NEXT STEP: Execute vendor consolidation wave transitioning 912 tail vendors to 180 certified partners</a:t>
             </a:r>
             <a:endParaRPr lang="en-US" sz="750" dirty="0"/>
           </a:p>
@@ -8921,7 +8921,7 @@
                   <a:srgbClr val="F8FAFC"/>
                 </a:solidFill>
               </a:rPr>
-              <a:t>FIND-03: E-Auction Dynamic Price Discovery Potential in Packaging &amp; Freight</a:t>
+              <a:t>FIND-03: Competitive Sourcing &amp; E-Auction Execution in Standardized Packaging</a:t>
             </a:r>
             <a:endParaRPr lang="en-US" sz="850" dirty="0"/>
           </a:p>
@@ -8993,7 +8993,7 @@
                   <a:srgbClr val="CBD5E1"/>
                 </a:solidFill>
               </a:rPr>
-              <a:t>BACKGROUND: Market suitability screening of liquid multi-supplier categories with high commodity dispersion.</a:t>
+              <a:t>BACKGROUND: E-auction is evaluated as one execution mechanism within the broader sourcing strategy</a:t>
             </a:r>
             <a:endParaRPr lang="en-US" sz="750" dirty="0"/>
           </a:p>
@@ -9013,7 +9013,7 @@
                   <a:srgbClr val="CBD5E1"/>
                 </a:solidFill>
               </a:rPr>
-              <a:t>EVIDENCE: Packaging (HDPE bags) and secondary outbound freight lanes feature 14+ qualified vendors.</a:t>
+              <a:t>EVIDENCE: Packaging materials (HDPE bags) feature 14+ qualified vendors and liquid supply market</a:t>
             </a:r>
             <a:endParaRPr lang="en-US" sz="750" dirty="0"/>
           </a:p>
@@ -9033,7 +9033,7 @@
                   <a:srgbClr val="CBD5E1"/>
                 </a:solidFill>
               </a:rPr>
-              <a:t>NEXT STEP: Prepare dynamic bidding rulebook and pre-qualify 14 regional packaging fabricators.</a:t>
+              <a:t>NEXT STEP: Prepare dynamic bidding rulebook and pre-qualify 14 regional packaging fabricators</a:t>
             </a:r>
             <a:endParaRPr lang="en-US" sz="750" dirty="0"/>
           </a:p>
@@ -9041,7 +9041,353 @@
       </p:sp>
       <p:sp>
         <p:nvSpPr>
-          <p:cNvPr id="17" name="Text 15"/>
+          <p:cNvPr id="17" name="Shape 15"/>
+          <p:cNvSpPr/>
+          <p:nvPr/>
+        </p:nvSpPr>
+        <p:spPr>
+          <a:xfrm>
+            <a:off x="8823960" y="914400"/>
+            <a:ext cx="2651760" cy="3657600"/>
+          </a:xfrm>
+          <a:prstGeom prst="rect">
+            <a:avLst/>
+          </a:prstGeom>
+          <a:solidFill>
+            <a:srgbClr val="1E293B"/>
+          </a:solidFill>
+          <a:ln w="12700">
+            <a:solidFill>
+              <a:srgbClr val="2563EB"/>
+            </a:solidFill>
+            <a:prstDash val="solid"/>
+          </a:ln>
+        </p:spPr>
+      </p:sp>
+      <p:sp>
+        <p:nvSpPr>
+          <p:cNvPr id="18" name="Text 16"/>
+          <p:cNvSpPr/>
+          <p:nvPr/>
+        </p:nvSpPr>
+        <p:spPr>
+          <a:xfrm>
+            <a:off x="8915400" y="1005840"/>
+            <a:ext cx="2468880" cy="457200"/>
+          </a:xfrm>
+          <a:prstGeom prst="rect">
+            <a:avLst/>
+          </a:prstGeom>
+          <a:noFill/>
+          <a:ln/>
+        </p:spPr>
+        <p:txBody>
+          <a:bodyPr wrap="square" rtlCol="0" anchor="ctr"/>
+          <a:lstStyle/>
+          <a:p>
+            <a:pPr indent="0" marL="0">
+              <a:buNone/>
+            </a:pPr>
+            <a:r>
+              <a:rPr lang="en-US" sz="850" b="1" dirty="0">
+                <a:solidFill>
+                  <a:srgbClr val="F8FAFC"/>
+                </a:solidFill>
+              </a:rPr>
+              <a:t>FIND-04: PCBI Benchmark Gap Independent Price Positioning in Energy &amp; Resins</a:t>
+            </a:r>
+            <a:endParaRPr lang="en-US" sz="850" dirty="0"/>
+          </a:p>
+        </p:txBody>
+      </p:sp>
+      <p:sp>
+        <p:nvSpPr>
+          <p:cNvPr id="19" name="Text 17"/>
+          <p:cNvSpPr/>
+          <p:nvPr/>
+        </p:nvSpPr>
+        <p:spPr>
+          <a:xfrm>
+            <a:off x="8915400" y="1508760"/>
+            <a:ext cx="2468880" cy="228600"/>
+          </a:xfrm>
+          <a:prstGeom prst="rect">
+            <a:avLst/>
+          </a:prstGeom>
+          <a:noFill/>
+          <a:ln/>
+        </p:spPr>
+        <p:txBody>
+          <a:bodyPr wrap="square" rtlCol="0" anchor="ctr"/>
+          <a:lstStyle/>
+          <a:p>
+            <a:pPr indent="0" marL="0">
+              <a:buNone/>
+            </a:pPr>
+            <a:r>
+              <a:rPr lang="en-US" sz="800" b="1" dirty="0">
+                <a:solidFill>
+                  <a:srgbClr val="38BDF8"/>
+                </a:solidFill>
+              </a:rPr>
+              <a:t>VALUE: ₹13.75 Cr | CONF: HIGH</a:t>
+            </a:r>
+            <a:endParaRPr lang="en-US" sz="800" dirty="0"/>
+          </a:p>
+        </p:txBody>
+      </p:sp>
+      <p:sp>
+        <p:nvSpPr>
+          <p:cNvPr id="20" name="Text 18"/>
+          <p:cNvSpPr/>
+          <p:nvPr/>
+        </p:nvSpPr>
+        <p:spPr>
+          <a:xfrm>
+            <a:off x="8915400" y="1783080"/>
+            <a:ext cx="2468880" cy="2560320"/>
+          </a:xfrm>
+          <a:prstGeom prst="rect">
+            <a:avLst/>
+          </a:prstGeom>
+          <a:noFill/>
+          <a:ln/>
+        </p:spPr>
+        <p:txBody>
+          <a:bodyPr wrap="square" rtlCol="0" anchor="ctr"/>
+          <a:lstStyle/>
+          <a:p>
+            <a:pPr indent="0" marL="0">
+              <a:buNone/>
+            </a:pPr>
+            <a:r>
+              <a:rPr lang="en-US" sz="750" dirty="0">
+                <a:solidFill>
+                  <a:srgbClr val="CBD5E1"/>
+                </a:solidFill>
+              </a:rPr>
+              <a:t>BACKGROUND: PCBI analysis identifies price-positioning opportunities independent of the sourcing mechanism</a:t>
+            </a:r>
+            <a:endParaRPr lang="en-US" sz="750" dirty="0"/>
+          </a:p>
+          <a:p>
+            <a:pPr indent="0" marL="0">
+              <a:buNone/>
+            </a:pPr>
+            <a:endParaRPr lang="en-US" sz="750" dirty="0"/>
+          </a:p>
+          <a:p>
+            <a:pPr indent="0" marL="0">
+              <a:buNone/>
+            </a:pPr>
+            <a:r>
+              <a:rPr lang="en-US" sz="750" dirty="0">
+                <a:solidFill>
+                  <a:srgbClr val="CBD5E1"/>
+                </a:solidFill>
+              </a:rPr>
+              <a:t>EVIDENCE: Imported petcoke and PP resin show 6.28% and 7.41% variance against PCBI benchmarks</a:t>
+            </a:r>
+            <a:endParaRPr lang="en-US" sz="750" dirty="0"/>
+          </a:p>
+          <a:p>
+            <a:pPr indent="0" marL="0">
+              <a:buNone/>
+            </a:pPr>
+            <a:endParaRPr lang="en-US" sz="750" dirty="0"/>
+          </a:p>
+          <a:p>
+            <a:pPr indent="0" marL="0">
+              <a:buNone/>
+            </a:pPr>
+            <a:r>
+              <a:rPr lang="en-US" sz="750" dirty="0">
+                <a:solidFill>
+                  <a:srgbClr val="CBD5E1"/>
+                </a:solidFill>
+              </a:rPr>
+              <a:t>NEXT STEP: Present audited PCBI benchmark gap dossiers during upcoming quarterly term contract renewals</a:t>
+            </a:r>
+            <a:endParaRPr lang="en-US" sz="750" dirty="0"/>
+          </a:p>
+        </p:txBody>
+      </p:sp>
+      <p:sp>
+        <p:nvSpPr>
+          <p:cNvPr id="21" name="Shape 19"/>
+          <p:cNvSpPr/>
+          <p:nvPr/>
+        </p:nvSpPr>
+        <p:spPr>
+          <a:xfrm>
+            <a:off x="11612880" y="914400"/>
+            <a:ext cx="2651760" cy="3657600"/>
+          </a:xfrm>
+          <a:prstGeom prst="rect">
+            <a:avLst/>
+          </a:prstGeom>
+          <a:solidFill>
+            <a:srgbClr val="1E293B"/>
+          </a:solidFill>
+          <a:ln w="12700">
+            <a:solidFill>
+              <a:srgbClr val="2563EB"/>
+            </a:solidFill>
+            <a:prstDash val="solid"/>
+          </a:ln>
+        </p:spPr>
+      </p:sp>
+      <p:sp>
+        <p:nvSpPr>
+          <p:cNvPr id="22" name="Text 20"/>
+          <p:cNvSpPr/>
+          <p:nvPr/>
+        </p:nvSpPr>
+        <p:spPr>
+          <a:xfrm>
+            <a:off x="11704320" y="1005840"/>
+            <a:ext cx="2468880" cy="457200"/>
+          </a:xfrm>
+          <a:prstGeom prst="rect">
+            <a:avLst/>
+          </a:prstGeom>
+          <a:noFill/>
+          <a:ln/>
+        </p:spPr>
+        <p:txBody>
+          <a:bodyPr wrap="square" rtlCol="0" anchor="ctr"/>
+          <a:lstStyle/>
+          <a:p>
+            <a:pPr indent="0" marL="0">
+              <a:buNone/>
+            </a:pPr>
+            <a:r>
+              <a:rPr lang="en-US" sz="850" b="1" dirty="0">
+                <a:solidFill>
+                  <a:srgbClr val="F8FAFC"/>
+                </a:solidFill>
+              </a:rPr>
+              <a:t>FIND-05: PO Consolidation &amp; Operational Process Effort Reduction</a:t>
+            </a:r>
+            <a:endParaRPr lang="en-US" sz="850" dirty="0"/>
+          </a:p>
+        </p:txBody>
+      </p:sp>
+      <p:sp>
+        <p:nvSpPr>
+          <p:cNvPr id="23" name="Text 21"/>
+          <p:cNvSpPr/>
+          <p:nvPr/>
+        </p:nvSpPr>
+        <p:spPr>
+          <a:xfrm>
+            <a:off x="11704320" y="1508760"/>
+            <a:ext cx="2468880" cy="228600"/>
+          </a:xfrm>
+          <a:prstGeom prst="rect">
+            <a:avLst/>
+          </a:prstGeom>
+          <a:noFill/>
+          <a:ln/>
+        </p:spPr>
+        <p:txBody>
+          <a:bodyPr wrap="square" rtlCol="0" anchor="ctr"/>
+          <a:lstStyle/>
+          <a:p>
+            <a:pPr indent="0" marL="0">
+              <a:buNone/>
+            </a:pPr>
+            <a:r>
+              <a:rPr lang="en-US" sz="800" b="1" dirty="0">
+                <a:solidFill>
+                  <a:srgbClr val="38BDF8"/>
+                </a:solidFill>
+              </a:rPr>
+              <a:t>VALUE: 20% Effort Reduction | CONF: HIGH</a:t>
+            </a:r>
+            <a:endParaRPr lang="en-US" sz="800" dirty="0"/>
+          </a:p>
+        </p:txBody>
+      </p:sp>
+      <p:sp>
+        <p:nvSpPr>
+          <p:cNvPr id="24" name="Text 22"/>
+          <p:cNvSpPr/>
+          <p:nvPr/>
+        </p:nvSpPr>
+        <p:spPr>
+          <a:xfrm>
+            <a:off x="11704320" y="1783080"/>
+            <a:ext cx="2468880" cy="2560320"/>
+          </a:xfrm>
+          <a:prstGeom prst="rect">
+            <a:avLst/>
+          </a:prstGeom>
+          <a:noFill/>
+          <a:ln/>
+        </p:spPr>
+        <p:txBody>
+          <a:bodyPr wrap="square" rtlCol="0" anchor="ctr"/>
+          <a:lstStyle/>
+          <a:p>
+            <a:pPr indent="0" marL="0">
+              <a:buNone/>
+            </a:pPr>
+            <a:r>
+              <a:rPr lang="en-US" sz="750" dirty="0">
+                <a:solidFill>
+                  <a:srgbClr val="CBD5E1"/>
+                </a:solidFill>
+              </a:rPr>
+              <a:t>BACKGROUND: PO consolidation represents operational productivity and manpower effort reduction, not spend savings</a:t>
+            </a:r>
+            <a:endParaRPr lang="en-US" sz="750" dirty="0"/>
+          </a:p>
+          <a:p>
+            <a:pPr indent="0" marL="0">
+              <a:buNone/>
+            </a:pPr>
+            <a:endParaRPr lang="en-US" sz="750" dirty="0"/>
+          </a:p>
+          <a:p>
+            <a:pPr indent="0" marL="0">
+              <a:buNone/>
+            </a:pPr>
+            <a:r>
+              <a:rPr lang="en-US" sz="750" dirty="0">
+                <a:solidFill>
+                  <a:srgbClr val="CBD5E1"/>
+                </a:solidFill>
+              </a:rPr>
+              <a:t>EVIDENCE: 4,120 micro-purchase orders generated annually across 18 manufacturing facilities</a:t>
+            </a:r>
+            <a:endParaRPr lang="en-US" sz="750" dirty="0"/>
+          </a:p>
+          <a:p>
+            <a:pPr indent="0" marL="0">
+              <a:buNone/>
+            </a:pPr>
+            <a:endParaRPr lang="en-US" sz="750" dirty="0"/>
+          </a:p>
+          <a:p>
+            <a:pPr indent="0" marL="0">
+              <a:buNone/>
+            </a:pPr>
+            <a:r>
+              <a:rPr lang="en-US" sz="750" dirty="0">
+                <a:solidFill>
+                  <a:srgbClr val="CBD5E1"/>
+                </a:solidFill>
+              </a:rPr>
+              <a:t>NEXT STEP: Configure ERP automatic batch replenishment for standardized plant consumables</a:t>
+            </a:r>
+            <a:endParaRPr lang="en-US" sz="750" dirty="0"/>
+          </a:p>
+        </p:txBody>
+      </p:sp>
+      <p:sp>
+        <p:nvSpPr>
+          <p:cNvPr id="25" name="Text 23"/>
           <p:cNvSpPr/>
           <p:nvPr/>
         </p:nvSpPr>
@@ -9080,7 +9426,7 @@
       </p:sp>
       <p:sp>
         <p:nvSpPr>
-          <p:cNvPr id="18" name="Text 16"/>
+          <p:cNvPr id="26" name="Text 24"/>
           <p:cNvSpPr/>
           <p:nvPr/>
         </p:nvSpPr>
@@ -11349,7 +11695,7 @@
                 <a:ea typeface="Arial" pitchFamily="34" charset="-122"/>
                 <a:cs typeface="Arial" pitchFamily="34" charset="-120"/>
               </a:rPr>
-              <a:t>E-Auction Opportunities: Dynamic Competitive Events</a:t>
+              <a:t>E-Auction Opportunities: Dynamic Competitive Events (One Sourcing Lever)</a:t>
             </a:r>
             <a:endParaRPr lang="en-US" sz="1400" dirty="0"/>
           </a:p>
@@ -11412,7 +11758,7 @@
         </p:nvGraphicFramePr>
         <p:xfrm>
           <a:off x="457200" y="1005840"/>
-          <a:ext cx="8229600" cy="3474720"/>
+          <a:ext cx="8229600" cy="2103120"/>
         </p:xfrm>
         <a:graphic>
           <a:graphicData uri="http://schemas.openxmlformats.org/drawingml/2006/table">
@@ -11425,7 +11771,7 @@
                 <a:gridCol w="1645920"/>
                 <a:gridCol w="1188720"/>
               </a:tblGrid>
-              <a:tr h="868680">
+              <a:tr h="525780">
                 <a:tc>
                   <a:txBody>
                     <a:bodyPr/>
@@ -11612,7 +11958,7 @@
                   </a:tcPr>
                 </a:tc>
               </a:tr>
-              <a:tr h="868680">
+              <a:tr h="525780">
                 <a:tc>
                   <a:txBody>
                     <a:bodyPr/>
@@ -11799,7 +12145,7 @@
                   </a:tcPr>
                 </a:tc>
               </a:tr>
-              <a:tr h="868680">
+              <a:tr h="525780">
                 <a:tc>
                   <a:txBody>
                     <a:bodyPr/>
@@ -11986,7 +12332,7 @@
                   </a:tcPr>
                 </a:tc>
               </a:tr>
-              <a:tr h="868680">
+              <a:tr h="525780">
                 <a:tc>
                   <a:txBody>
                     <a:bodyPr/>
@@ -12179,7 +12525,116 @@
       </p:graphicFrame>
       <p:sp>
         <p:nvSpPr>
-          <p:cNvPr id="6" name="Text 3"/>
+          <p:cNvPr id="6" name="Shape 3"/>
+          <p:cNvSpPr/>
+          <p:nvPr/>
+        </p:nvSpPr>
+        <p:spPr>
+          <a:xfrm>
+            <a:off x="457200" y="3200400"/>
+            <a:ext cx="8229600" cy="1280160"/>
+          </a:xfrm>
+          <a:prstGeom prst="rect">
+            <a:avLst/>
+          </a:prstGeom>
+          <a:solidFill>
+            <a:srgbClr val="1E293B"/>
+          </a:solidFill>
+          <a:ln w="12700">
+            <a:solidFill>
+              <a:srgbClr val="F59E0B"/>
+            </a:solidFill>
+            <a:prstDash val="solid"/>
+          </a:ln>
+        </p:spPr>
+      </p:sp>
+      <p:sp>
+        <p:nvSpPr>
+          <p:cNvPr id="7" name="Text 4"/>
+          <p:cNvSpPr/>
+          <p:nvPr/>
+        </p:nvSpPr>
+        <p:spPr>
+          <a:xfrm>
+            <a:off x="640080" y="3291840"/>
+            <a:ext cx="7863840" cy="1097280"/>
+          </a:xfrm>
+          <a:prstGeom prst="rect">
+            <a:avLst/>
+          </a:prstGeom>
+          <a:noFill/>
+          <a:ln/>
+        </p:spPr>
+        <p:txBody>
+          <a:bodyPr wrap="square" rtlCol="0" anchor="ctr"/>
+          <a:lstStyle/>
+          <a:p>
+            <a:pPr indent="0" marL="0">
+              <a:buNone/>
+            </a:pPr>
+            <a:r>
+              <a:rPr lang="en-US" sz="850" dirty="0">
+                <a:solidFill>
+                  <a:srgbClr val="CBD5E1"/>
+                </a:solidFill>
+              </a:rPr>
+              <a:t>E-AUCTION POSITIONING &amp; REQUISITE CONDITIONS</a:t>
+            </a:r>
+            <a:endParaRPr lang="en-US" sz="850" dirty="0"/>
+          </a:p>
+          <a:p>
+            <a:pPr indent="0" marL="0">
+              <a:buNone/>
+            </a:pPr>
+            <a:endParaRPr lang="en-US" sz="850" dirty="0"/>
+          </a:p>
+          <a:p>
+            <a:pPr indent="0" marL="0">
+              <a:buNone/>
+            </a:pPr>
+            <a:r>
+              <a:rPr lang="en-US" sz="850" dirty="0">
+                <a:solidFill>
+                  <a:srgbClr val="CBD5E1"/>
+                </a:solidFill>
+              </a:rPr>
+              <a:t>• E-auction is one of several sourcing mechanisms evaluated and is not assumed to be applicable to the entire addressable spend.</a:t>
+            </a:r>
+            <a:endParaRPr lang="en-US" sz="850" dirty="0"/>
+          </a:p>
+          <a:p>
+            <a:pPr indent="0" marL="0">
+              <a:buNone/>
+            </a:pPr>
+            <a:r>
+              <a:rPr lang="en-US" sz="850" dirty="0">
+                <a:solidFill>
+                  <a:srgbClr val="CBD5E1"/>
+                </a:solidFill>
+              </a:rPr>
+              <a:t>• Applicable strictly to categories with standardized technical specifications and 5+ qualified, liquid market participants.</a:t>
+            </a:r>
+            <a:endParaRPr lang="en-US" sz="850" dirty="0"/>
+          </a:p>
+          <a:p>
+            <a:pPr indent="0" marL="0">
+              <a:buNone/>
+            </a:pPr>
+            <a:r>
+              <a:rPr lang="en-US" sz="850" dirty="0">
+                <a:solidFill>
+                  <a:srgbClr val="CBD5E1"/>
+                </a:solidFill>
+              </a:rPr>
+              <a:t>• Non-standardized, sole-source, or highly specialized categories are routed to bilateral negotiation and technical RFQ.</a:t>
+            </a:r>
+            <a:endParaRPr lang="en-US" sz="850" dirty="0"/>
+          </a:p>
+        </p:txBody>
+      </p:sp>
+      <p:sp>
+        <p:nvSpPr>
+          <p:cNvPr id="8" name="Text 5"/>
           <p:cNvSpPr/>
           <p:nvPr/>
         </p:nvSpPr>
@@ -12218,7 +12673,7 @@
       </p:sp>
       <p:sp>
         <p:nvSpPr>
-          <p:cNvPr id="7" name="Text 4"/>
+          <p:cNvPr id="9" name="Text 6"/>
           <p:cNvSpPr/>
           <p:nvPr/>
         </p:nvSpPr>
@@ -12361,7 +12816,7 @@
                 <a:ea typeface="Arial" pitchFamily="34" charset="-122"/>
                 <a:cs typeface="Arial" pitchFamily="34" charset="-120"/>
               </a:rPr>
-              <a:t>Vendor Base Consolidation: Tail Spend Rationalization</a:t>
+              <a:t>Vendor Base Consolidation: Tail Spend Rationalization (5% Modelling Assumption)</a:t>
             </a:r>
             <a:endParaRPr lang="en-US" sz="1400" dirty="0"/>
           </a:p>
@@ -12424,7 +12879,7 @@
         </p:nvGraphicFramePr>
         <p:xfrm>
           <a:off x="457200" y="1005840"/>
-          <a:ext cx="8229600" cy="3474720"/>
+          <a:ext cx="8229600" cy="2103120"/>
         </p:xfrm>
         <a:graphic>
           <a:graphicData uri="http://schemas.openxmlformats.org/drawingml/2006/table">
@@ -12436,7 +12891,7 @@
                 <a:gridCol w="2560320"/>
                 <a:gridCol w="1097280"/>
               </a:tblGrid>
-              <a:tr h="1158240">
+              <a:tr h="701040">
                 <a:tc>
                   <a:txBody>
                     <a:bodyPr/>
@@ -12586,7 +13041,7 @@
                   </a:tcPr>
                 </a:tc>
               </a:tr>
-              <a:tr h="1158240">
+              <a:tr h="701040">
                 <a:tc>
                   <a:txBody>
                     <a:bodyPr/>
@@ -12736,7 +13191,7 @@
                   </a:tcPr>
                 </a:tc>
               </a:tr>
-              <a:tr h="1158240">
+              <a:tr h="701040">
                 <a:tc>
                   <a:txBody>
                     <a:bodyPr/>
@@ -12892,7 +13347,116 @@
       </p:graphicFrame>
       <p:sp>
         <p:nvSpPr>
-          <p:cNvPr id="6" name="Text 3"/>
+          <p:cNvPr id="6" name="Shape 3"/>
+          <p:cNvSpPr/>
+          <p:nvPr/>
+        </p:nvSpPr>
+        <p:spPr>
+          <a:xfrm>
+            <a:off x="457200" y="3200400"/>
+            <a:ext cx="8229600" cy="1280160"/>
+          </a:xfrm>
+          <a:prstGeom prst="rect">
+            <a:avLst/>
+          </a:prstGeom>
+          <a:solidFill>
+            <a:srgbClr val="1E293B"/>
+          </a:solidFill>
+          <a:ln w="12700">
+            <a:solidFill>
+              <a:srgbClr val="10B981"/>
+            </a:solidFill>
+            <a:prstDash val="solid"/>
+          </a:ln>
+        </p:spPr>
+      </p:sp>
+      <p:sp>
+        <p:nvSpPr>
+          <p:cNvPr id="7" name="Text 4"/>
+          <p:cNvSpPr/>
+          <p:nvPr/>
+        </p:nvSpPr>
+        <p:spPr>
+          <a:xfrm>
+            <a:off x="640080" y="3291840"/>
+            <a:ext cx="7863840" cy="1097280"/>
+          </a:xfrm>
+          <a:prstGeom prst="rect">
+            <a:avLst/>
+          </a:prstGeom>
+          <a:noFill/>
+          <a:ln/>
+        </p:spPr>
+        <p:txBody>
+          <a:bodyPr wrap="square" rtlCol="0" anchor="ctr"/>
+          <a:lstStyle/>
+          <a:p>
+            <a:pPr indent="0" marL="0">
+              <a:buNone/>
+            </a:pPr>
+            <a:r>
+              <a:rPr lang="en-US" sz="850" dirty="0">
+                <a:solidFill>
+                  <a:srgbClr val="CBD5E1"/>
+                </a:solidFill>
+              </a:rPr>
+              <a:t>CONSOLIDATION MODELLING ASSUMPTION &amp; GOVERNANCE</a:t>
+            </a:r>
+            <a:endParaRPr lang="en-US" sz="850" dirty="0"/>
+          </a:p>
+          <a:p>
+            <a:pPr indent="0" marL="0">
+              <a:buNone/>
+            </a:pPr>
+            <a:endParaRPr lang="en-US" sz="850" dirty="0"/>
+          </a:p>
+          <a:p>
+            <a:pPr indent="0" marL="0">
+              <a:buNone/>
+            </a:pPr>
+            <a:r>
+              <a:rPr lang="en-US" sz="850" dirty="0">
+                <a:solidFill>
+                  <a:srgbClr val="CBD5E1"/>
+                </a:solidFill>
+              </a:rPr>
+              <a:t>• Based on supplier fragmentation identified in the analysed spend, consolidation of eligible volumes may create additional purchasing leverage. An indicative 5% volume-discount assumption has been applied for opportunity modelling.</a:t>
+            </a:r>
+            <a:endParaRPr lang="en-US" sz="850" dirty="0"/>
+          </a:p>
+          <a:p>
+            <a:pPr indent="0" marL="0">
+              <a:buNone/>
+            </a:pPr>
+            <a:r>
+              <a:rPr lang="en-US" sz="850" dirty="0">
+                <a:solidFill>
+                  <a:srgbClr val="CBD5E1"/>
+                </a:solidFill>
+              </a:rPr>
+              <a:t>• Actual realization will depend on supplier negotiations, market conditions, specifications and competitive intensity.</a:t>
+            </a:r>
+            <a:endParaRPr lang="en-US" sz="850" dirty="0"/>
+          </a:p>
+          <a:p>
+            <a:pPr indent="0" marL="0">
+              <a:buNone/>
+            </a:pPr>
+            <a:r>
+              <a:rPr lang="en-US" sz="850" dirty="0">
+                <a:solidFill>
+                  <a:srgbClr val="CBD5E1"/>
+                </a:solidFill>
+              </a:rPr>
+              <a:t>• Transition preserves emergency supply via localized vendor-managed consignment stocking.</a:t>
+            </a:r>
+            <a:endParaRPr lang="en-US" sz="850" dirty="0"/>
+          </a:p>
+        </p:txBody>
+      </p:sp>
+      <p:sp>
+        <p:nvSpPr>
+          <p:cNvPr id="8" name="Text 5"/>
           <p:cNvSpPr/>
           <p:nvPr/>
         </p:nvSpPr>
@@ -12931,7 +13495,7 @@
       </p:sp>
       <p:sp>
         <p:nvSpPr>
-          <p:cNvPr id="7" name="Text 4"/>
+          <p:cNvPr id="9" name="Text 6"/>
           <p:cNvSpPr/>
           <p:nvPr/>
         </p:nvSpPr>

</xml_diff>